<commit_message>
Align dataset wording with RecSys feature schema
</commit_message>
<xml_diff>
--- a/docs/distributweet_final_presentation.pptx
+++ b/docs/distributweet_final_presentation.pptx
@@ -2156,7 +2156,7 @@
                   <a:srgbClr val="17201C"/>
                 </a:solidFill>
               </a:rPr>
-              <a:t>- Default demo uses schema-compatible synthetic records.</a:t>
+              <a:t>- Default demo uses feature-schema-compatible synthetic records.</a:t>
             </a:r>
             <a:endParaRPr lang="en-US" sz="1800"/>
           </a:p>
@@ -2297,7 +2297,7 @@
                   <a:srgbClr val="17201C"/>
                 </a:solidFill>
               </a:rPr>
-              <a:t>- data-generator/generator.py creates twenty-column TSV rows.</a:t>
+              <a:t>- data-generator/generator.py creates RecSys-style feature TSV rows.</a:t>
             </a:r>
             <a:endParaRPr lang="en-US" sz="1800"/>
           </a:p>
@@ -2341,7 +2341,7 @@
                   <a:srgbClr val="17201C"/>
                 </a:solidFill>
               </a:rPr>
-              <a:t>- The same downstream services consume synthetic or file-based rows.</a:t>
+              <a:t>- Extra engagement label columns can be ignored by the content pipeline.</a:t>
             </a:r>
             <a:endParaRPr lang="en-US" sz="1800"/>
           </a:p>

</xml_diff>

<commit_message>
Switch demo dataset to Bright Data Twitter X sample
</commit_message>
<xml_diff>
--- a/docs/distributweet_final_presentation.pptx
+++ b/docs/distributweet_final_presentation.pptx
@@ -1253,6 +1253,17 @@
                   <a:srgbClr val="17201C"/>
                 </a:solidFill>
               </a:rPr>
+              <a:t>- Python tests cover Bright Data CSV conversion.</a:t>
+            </a:r>
+            <a:endParaRPr lang="en-US" sz="1800"/>
+          </a:p>
+          <a:p>
+            <a:r>
+              <a:rPr lang="en-US" sz="1800">
+                <a:solidFill>
+                  <a:srgbClr val="17201C"/>
+                </a:solidFill>
+              </a:rPr>
               <a:t>- Scala tests run during Docker builds.</a:t>
             </a:r>
             <a:endParaRPr lang="en-US" sz="1800"/>
@@ -1449,18 +1460,29 @@
                   <a:srgbClr val="17201C"/>
                 </a:solidFill>
               </a:rPr>
-              <a:t>- Local data are synthetic unless real compatible TSV is supplied.</a:t>
-            </a:r>
-            <a:endParaRPr lang="en-US" sz="1800"/>
-          </a:p>
-          <a:p>
-            <a:r>
-              <a:rPr lang="en-US" sz="1800">
-                <a:solidFill>
-                  <a:srgbClr val="17201C"/>
-                </a:solidFill>
-              </a:rPr>
-              <a:t>- Future: use engagement labels, train ranking model, evaluate NDCG.</a:t>
+              <a:t>- Public sample is small and not topic-balanced.</a:t>
+            </a:r>
+            <a:endParaRPr lang="en-US" sz="1800"/>
+          </a:p>
+          <a:p>
+            <a:r>
+              <a:rPr lang="en-US" sz="1800">
+                <a:solidFill>
+                  <a:srgbClr val="17201C"/>
+                </a:solidFill>
+              </a:rPr>
+              <a:t>- Future: process larger Bright Data export, e.g. 20M records.</a:t>
+            </a:r>
+            <a:endParaRPr lang="en-US" sz="1800"/>
+          </a:p>
+          <a:p>
+            <a:r>
+              <a:rPr lang="en-US" sz="1800">
+                <a:solidFill>
+                  <a:srgbClr val="17201C"/>
+                </a:solidFill>
+              </a:rPr>
+              <a:t>- Future: use engagement counts, train ranking model, evaluate NDCG.</a:t>
             </a:r>
             <a:endParaRPr lang="en-US" sz="1800"/>
           </a:p>
@@ -1612,7 +1634,7 @@
                   <a:srgbClr val="17201C"/>
                 </a:solidFill>
               </a:rPr>
-              <a:t>- RecSys 2021 schema and local data generation.</a:t>
+              <a:t>- Bright Data Twitter/X sample and larger 20M source.</a:t>
             </a:r>
             <a:endParaRPr lang="en-US" sz="1800"/>
           </a:p>
@@ -1960,6 +1982,17 @@
                   <a:srgbClr val="17201C"/>
                 </a:solidFill>
               </a:rPr>
+              <a:t>- Implemented: Bright Data CSV-to-stream adapter.</a:t>
+            </a:r>
+            <a:endParaRPr lang="en-US" sz="1800"/>
+          </a:p>
+          <a:p>
+            <a:r>
+              <a:rPr lang="en-US" sz="1800">
+                <a:solidFill>
+                  <a:srgbClr val="17201C"/>
+                </a:solidFill>
+              </a:rPr>
               <a:t>- Implemented: deduplication, embeddings, vector search.</a:t>
             </a:r>
             <a:endParaRPr lang="en-US" sz="1800"/>
@@ -2088,7 +2121,7 @@
                   <a:srgbClr val="0F766E"/>
                 </a:solidFill>
               </a:rPr>
-              <a:t>Dataset Target</a:t>
+              <a:t>Dataset Source</a:t>
             </a:r>
             <a:endParaRPr lang="en-US" sz="3800"/>
           </a:p>
@@ -2123,51 +2156,51 @@
                   <a:srgbClr val="17201C"/>
                 </a:solidFill>
               </a:rPr>
-              <a:t>- Target schema: Twitter RecSys Challenge 2021.</a:t>
-            </a:r>
-            <a:endParaRPr lang="en-US" sz="1800"/>
-          </a:p>
-          <a:p>
-            <a:r>
-              <a:rPr lang="en-US" sz="1800">
-                <a:solidFill>
-                  <a:srgbClr val="17201C"/>
-                </a:solidFill>
-              </a:rPr>
-              <a:t>- Original task: tweet engagement prediction and fairness.</a:t>
-            </a:r>
-            <a:endParaRPr lang="en-US" sz="1800"/>
-          </a:p>
-          <a:p>
-            <a:r>
-              <a:rPr lang="en-US" sz="1800">
-                <a:solidFill>
-                  <a:srgbClr val="17201C"/>
-                </a:solidFill>
-              </a:rPr>
-              <a:t>- Tweet text is distributed as multilingual BERT token IDs.</a:t>
-            </a:r>
-            <a:endParaRPr lang="en-US" sz="1800"/>
-          </a:p>
-          <a:p>
-            <a:r>
-              <a:rPr lang="en-US" sz="1800">
-                <a:solidFill>
-                  <a:srgbClr val="17201C"/>
-                </a:solidFill>
-              </a:rPr>
-              <a:t>- Default demo uses feature-schema-compatible synthetic records.</a:t>
-            </a:r>
-            <a:endParaRPr lang="en-US" sz="1800"/>
-          </a:p>
-          <a:p>
-            <a:r>
-              <a:rPr lang="en-US" sz="1800">
-                <a:solidFill>
-                  <a:srgbClr val="17201C"/>
-                </a:solidFill>
-              </a:rPr>
-              <a:t>- Compatible real TSV can be replayed with --input-tsv.</a:t>
+              <a:t>- Default data: Bright Data Twitter/X posts sample.</a:t>
+            </a:r>
+            <a:endParaRPr lang="en-US" sz="1800"/>
+          </a:p>
+          <a:p>
+            <a:r>
+              <a:rPr lang="en-US" sz="1800">
+                <a:solidFill>
+                  <a:srgbClr val="17201C"/>
+                </a:solidFill>
+              </a:rPr>
+              <a:t>- Source repo: luminati-io/Twitter-X-dataset-samples.</a:t>
+            </a:r>
+            <a:endParaRPr lang="en-US" sz="1800"/>
+          </a:p>
+          <a:p>
+            <a:r>
+              <a:rPr lang="en-US" sz="1800">
+                <a:solidFill>
+                  <a:srgbClr val="17201C"/>
+                </a:solidFill>
+              </a:rPr>
+              <a:t>- Local demo replays 1000 public post rows.</a:t>
+            </a:r>
+            <a:endParaRPr lang="en-US" sz="1800"/>
+          </a:p>
+          <a:p>
+            <a:r>
+              <a:rPr lang="en-US" sz="1800">
+                <a:solidFill>
+                  <a:srgbClr val="17201C"/>
+                </a:solidFill>
+              </a:rPr>
+              <a:t>- Fields include description, date, hashtags, engagement counts.</a:t>
+            </a:r>
+            <a:endParaRPr lang="en-US" sz="1800"/>
+          </a:p>
+          <a:p>
+            <a:r>
+              <a:rPr lang="en-US" sz="1800">
+                <a:solidFill>
+                  <a:srgbClr val="17201C"/>
+                </a:solidFill>
+              </a:rPr>
+              <a:t>- Databricks Marketplace lists a larger 20M record dataset.</a:t>
             </a:r>
             <a:endParaRPr lang="en-US" sz="1800"/>
           </a:p>
@@ -2262,7 +2295,7 @@
                   <a:srgbClr val="0F766E"/>
                 </a:solidFill>
               </a:rPr>
-              <a:t>Data Generation</a:t>
+              <a:t>Data Adapter</a:t>
             </a:r>
             <a:endParaRPr lang="en-US" sz="3800"/>
           </a:p>
@@ -2297,51 +2330,51 @@
                   <a:srgbClr val="17201C"/>
                 </a:solidFill>
               </a:rPr>
-              <a:t>- data-generator/generator.py creates RecSys-style feature TSV rows.</a:t>
-            </a:r>
-            <a:endParaRPr lang="en-US" sz="1800"/>
-          </a:p>
-          <a:p>
-            <a:r>
-              <a:rPr lang="en-US" sz="1800">
-                <a:solidFill>
-                  <a:srgbClr val="17201C"/>
-                </a:solidFill>
-              </a:rPr>
-              <a:t>- Topic pools cover technology, sports, food, travel, finance, art, and more.</a:t>
-            </a:r>
-            <a:endParaRPr lang="en-US" sz="1800"/>
-          </a:p>
-          <a:p>
-            <a:r>
-              <a:rPr lang="en-US" sz="1800">
-                <a:solidFill>
-                  <a:srgbClr val="17201C"/>
-                </a:solidFill>
-              </a:rPr>
-              <a:t>- text_tokens uses real bert-base-multilingual-cased token IDs.</a:t>
-            </a:r>
-            <a:endParaRPr lang="en-US" sz="1800"/>
-          </a:p>
-          <a:p>
-            <a:r>
-              <a:rPr lang="en-US" sz="1800">
-                <a:solidFill>
-                  <a:srgbClr val="17201C"/>
-                </a:solidFill>
-              </a:rPr>
-              <a:t>- Rate and total message count are configurable.</a:t>
-            </a:r>
-            <a:endParaRPr lang="en-US" sz="1800"/>
-          </a:p>
-          <a:p>
-            <a:r>
-              <a:rPr lang="en-US" sz="1800">
-                <a:solidFill>
-                  <a:srgbClr val="17201C"/>
-                </a:solidFill>
-              </a:rPr>
-              <a:t>- Extra engagement label columns can be ignored by the content pipeline.</a:t>
+              <a:t>- data-generator/brightdata.py reads CSV URL or local CSV.</a:t>
+            </a:r>
+            <a:endParaRPr lang="en-US" sz="1800"/>
+          </a:p>
+          <a:p>
+            <a:r>
+              <a:rPr lang="en-US" sz="1800">
+                <a:solidFill>
+                  <a:srgbClr val="17201C"/>
+                </a:solidFill>
+              </a:rPr>
+              <a:t>- description is tokenized with bert-base-multilingual-cased.</a:t>
+            </a:r>
+            <a:endParaRPr lang="en-US" sz="1800"/>
+          </a:p>
+          <a:p>
+            <a:r>
+              <a:rPr lang="en-US" sz="1800">
+                <a:solidFill>
+                  <a:srgbClr val="17201C"/>
+                </a:solidFill>
+              </a:rPr>
+              <a:t>- date_posted becomes Unix timestamp.</a:t>
+            </a:r>
+            <a:endParaRPr lang="en-US" sz="1800"/>
+          </a:p>
+          <a:p>
+            <a:r>
+              <a:rPr lang="en-US" sz="1800">
+                <a:solidFill>
+                  <a:srgbClr val="17201C"/>
+                </a:solidFill>
+              </a:rPr>
+              <a:t>- user, hashtag, media, and follower metadata are mapped.</a:t>
+            </a:r>
+            <a:endParaRPr lang="en-US" sz="1800"/>
+          </a:p>
+          <a:p>
+            <a:r>
+              <a:rPr lang="en-US" sz="1800">
+                <a:solidFill>
+                  <a:srgbClr val="17201C"/>
+                </a:solidFill>
+              </a:rPr>
+              <a:t>- TOTAL_MESSAGES supports first 10, 100, 1000, or more rows.</a:t>
             </a:r>
             <a:endParaRPr lang="en-US" sz="1800"/>
           </a:p>
@@ -2471,7 +2504,18 @@
                   <a:srgbClr val="17201C"/>
                 </a:solidFill>
               </a:rPr>
-              <a:t>- data-generator or optional TSV file.</a:t>
+              <a:t>- Bright Data CSV sample.</a:t>
+            </a:r>
+            <a:endParaRPr lang="en-US" sz="1800"/>
+          </a:p>
+          <a:p>
+            <a:r>
+              <a:rPr lang="en-US" sz="1800">
+                <a:solidFill>
+                  <a:srgbClr val="17201C"/>
+                </a:solidFill>
+              </a:rPr>
+              <a:t>- CSV-to-TSV adapter.</a:t>
             </a:r>
             <a:endParaRPr lang="en-US" sz="1800"/>
           </a:p>
@@ -2885,7 +2929,7 @@
                   <a:srgbClr val="17201C"/>
                 </a:solidFill>
               </a:rPr>
-              <a:t>- Services can scale without changing the event schema.</a:t>
+              <a:t>- Larger datasets reuse the same schema and batching boundary.</a:t>
             </a:r>
             <a:endParaRPr lang="en-US" sz="1800"/>
           </a:p>

</xml_diff>